<commit_message>
se modifico la ppt
</commit_message>
<xml_diff>
--- a/Motor_Scoring_Clean_Architecture.pptx
+++ b/Motor_Scoring_Clean_Architecture.pptx
@@ -1870,8 +1870,9 @@
             </a:endParaRPr>
           </a:p>
           <a:p>
-            <a:pPr marL="0" indent="0">
-              <a:buNone/>
+            <a:pPr marL="171450" indent="-171450">
+              <a:buFontTx/>
+              <a:buChar char="-"/>
             </a:pPr>
             <a:r>
               <a:rPr lang="en-US" sz="1200" dirty="0">
@@ -1881,7 +1882,31 @@
                 <a:latin typeface="Arial" pitchFamily="34" charset="0"/>
                 <a:cs typeface="Arial" pitchFamily="34" charset="-120"/>
               </a:rPr>
-              <a:t>- José Julca</a:t>
+              <a:t>José Julca</a:t>
+            </a:r>
+          </a:p>
+          <a:p>
+            <a:r>
+              <a:rPr lang="en-US" sz="1200" dirty="0">
+                <a:solidFill>
+                  <a:srgbClr val="6B84A3"/>
+                </a:solidFill>
+                <a:latin typeface="Arial" pitchFamily="34" charset="0"/>
+                <a:cs typeface="Arial" pitchFamily="34" charset="-120"/>
+              </a:rPr>
+              <a:t>-  José Huaman </a:t>
+            </a:r>
+          </a:p>
+          <a:p>
+            <a:r>
+              <a:rPr lang="en-US" sz="1200" dirty="0">
+                <a:solidFill>
+                  <a:srgbClr val="6B84A3"/>
+                </a:solidFill>
+                <a:latin typeface="Arial" pitchFamily="34" charset="0"/>
+                <a:cs typeface="Arial" pitchFamily="34" charset="-120"/>
+              </a:rPr>
+              <a:t>-  Jhonatan Barrientos</a:t>
             </a:r>
             <a:endParaRPr lang="en-US" sz="1200" dirty="0"/>
           </a:p>

</xml_diff>